<commit_message>
#11 Update PAVEL_7_UCT_hackathon_2026.pptx with new content
</commit_message>
<xml_diff>
--- a/PAVEL_7_UCT_hackathon_2026.pptx
+++ b/PAVEL_7_UCT_hackathon_2026.pptx
@@ -5,54 +5,55 @@
     <p:sldMasterId id="2147483653" r:id="rId1"/>
   </p:sldMasterIdLst>
   <p:notesMasterIdLst>
-    <p:notesMasterId r:id="rId11"/>
+    <p:notesMasterId r:id="rId12"/>
   </p:notesMasterIdLst>
   <p:sldIdLst>
     <p:sldId id="256" r:id="rId2"/>
     <p:sldId id="257" r:id="rId3"/>
     <p:sldId id="258" r:id="rId4"/>
     <p:sldId id="259" r:id="rId5"/>
-    <p:sldId id="264" r:id="rId6"/>
-    <p:sldId id="263" r:id="rId7"/>
-    <p:sldId id="260" r:id="rId8"/>
-    <p:sldId id="261" r:id="rId9"/>
-    <p:sldId id="262" r:id="rId10"/>
+    <p:sldId id="265" r:id="rId6"/>
+    <p:sldId id="264" r:id="rId7"/>
+    <p:sldId id="263" r:id="rId8"/>
+    <p:sldId id="260" r:id="rId9"/>
+    <p:sldId id="261" r:id="rId10"/>
+    <p:sldId id="262" r:id="rId11"/>
   </p:sldIdLst>
   <p:sldSz cx="9144000" cy="5143500" type="screen16x9"/>
   <p:notesSz cx="6858000" cy="9144000"/>
   <p:embeddedFontLst>
     <p:embeddedFont>
       <p:font typeface="Helvetica Neue" panose="020B0604020202020204" charset="0"/>
-      <p:regular r:id="rId12"/>
-      <p:bold r:id="rId13"/>
-      <p:italic r:id="rId14"/>
-      <p:boldItalic r:id="rId15"/>
+      <p:regular r:id="rId13"/>
+      <p:bold r:id="rId14"/>
+      <p:italic r:id="rId15"/>
+      <p:boldItalic r:id="rId16"/>
     </p:embeddedFont>
     <p:embeddedFont>
       <p:font typeface="Libre Franklin" pitchFamily="2" charset="0"/>
-      <p:regular r:id="rId16"/>
-      <p:bold r:id="rId17"/>
-      <p:italic r:id="rId18"/>
-      <p:boldItalic r:id="rId19"/>
+      <p:regular r:id="rId17"/>
+      <p:bold r:id="rId18"/>
+      <p:italic r:id="rId19"/>
+      <p:boldItalic r:id="rId20"/>
     </p:embeddedFont>
     <p:embeddedFont>
       <p:font typeface="Titillium Web" panose="00000500000000000000" pitchFamily="2" charset="0"/>
-      <p:regular r:id="rId20"/>
-      <p:bold r:id="rId21"/>
-      <p:italic r:id="rId22"/>
-      <p:boldItalic r:id="rId23"/>
+      <p:regular r:id="rId21"/>
+      <p:bold r:id="rId22"/>
+      <p:italic r:id="rId23"/>
+      <p:boldItalic r:id="rId24"/>
     </p:embeddedFont>
     <p:embeddedFont>
       <p:font typeface="Titillium Web Light" panose="00000400000000000000" pitchFamily="2" charset="0"/>
-      <p:regular r:id="rId24"/>
-      <p:italic r:id="rId25"/>
+      <p:regular r:id="rId25"/>
+      <p:italic r:id="rId26"/>
     </p:embeddedFont>
     <p:embeddedFont>
       <p:font typeface="Titillium Web SemiBold" panose="00000700000000000000" pitchFamily="2" charset="0"/>
-      <p:regular r:id="rId26"/>
-      <p:bold r:id="rId27"/>
-      <p:italic r:id="rId28"/>
-      <p:boldItalic r:id="rId29"/>
+      <p:regular r:id="rId27"/>
+      <p:bold r:id="rId28"/>
+      <p:italic r:id="rId29"/>
+      <p:boldItalic r:id="rId30"/>
     </p:embeddedFont>
   </p:embeddedFontLst>
   <p:defaultTextStyle>
@@ -1023,6 +1024,135 @@
 </p:notes>
 </file>
 
+<file path=ppt/notesSlides/notesSlide10.xml><?xml version="1.0" encoding="utf-8"?>
+<p:notes xmlns:a="http://schemas.openxmlformats.org/drawingml/2006/main" xmlns:r="http://schemas.openxmlformats.org/officeDocument/2006/relationships" xmlns:p="http://schemas.openxmlformats.org/presentationml/2006/main" showMasterSp="0" showMasterPhAnim="0">
+  <p:cSld>
+    <p:spTree>
+      <p:nvGrpSpPr>
+        <p:cNvPr id="1" name="Shape 78"/>
+        <p:cNvGrpSpPr/>
+        <p:nvPr/>
+      </p:nvGrpSpPr>
+      <p:grpSpPr>
+        <a:xfrm>
+          <a:off x="0" y="0"/>
+          <a:ext cx="0" cy="0"/>
+          <a:chOff x="0" y="0"/>
+          <a:chExt cx="0" cy="0"/>
+        </a:xfrm>
+      </p:grpSpPr>
+      <p:sp>
+        <p:nvSpPr>
+          <p:cNvPr id="79" name="Google Shape;79;p7:notes"/>
+          <p:cNvSpPr txBox="1">
+            <a:spLocks noGrp="1"/>
+          </p:cNvSpPr>
+          <p:nvPr>
+            <p:ph type="body" idx="1"/>
+          </p:nvPr>
+        </p:nvSpPr>
+        <p:spPr>
+          <a:xfrm>
+            <a:off x="914400" y="4343400"/>
+            <a:ext cx="5029200" cy="4114800"/>
+          </a:xfrm>
+          <a:prstGeom prst="rect">
+            <a:avLst/>
+          </a:prstGeom>
+          <a:noFill/>
+          <a:ln>
+            <a:noFill/>
+          </a:ln>
+        </p:spPr>
+        <p:txBody>
+          <a:bodyPr spcFirstLastPara="1" wrap="square" lIns="91425" tIns="91425" rIns="91425" bIns="91425" anchor="t" anchorCtr="0">
+            <a:noAutofit/>
+          </a:bodyPr>
+          <a:lstStyle/>
+          <a:p>
+            <a:pPr marL="0" lvl="0" indent="0" algn="l" rtl="0">
+              <a:lnSpc>
+                <a:spcPct val="100000"/>
+              </a:lnSpc>
+              <a:spcBef>
+                <a:spcPts val="0"/>
+              </a:spcBef>
+              <a:spcAft>
+                <a:spcPts val="0"/>
+              </a:spcAft>
+              <a:buSzPts val="1100"/>
+              <a:buNone/>
+            </a:pPr>
+            <a:endParaRPr/>
+          </a:p>
+        </p:txBody>
+      </p:sp>
+      <p:sp>
+        <p:nvSpPr>
+          <p:cNvPr id="80" name="Google Shape;80;p7:notes"/>
+          <p:cNvSpPr>
+            <a:spLocks noGrp="1" noRot="1" noChangeAspect="1"/>
+          </p:cNvSpPr>
+          <p:nvPr>
+            <p:ph type="sldImg" idx="2"/>
+          </p:nvPr>
+        </p:nvSpPr>
+        <p:spPr>
+          <a:xfrm>
+            <a:off x="1143000" y="685800"/>
+            <a:ext cx="4572000" cy="3429000"/>
+          </a:xfrm>
+          <a:custGeom>
+            <a:avLst/>
+            <a:gdLst/>
+            <a:ahLst/>
+            <a:cxnLst/>
+            <a:rect l="l" t="t" r="r" b="b"/>
+            <a:pathLst>
+              <a:path w="120000" h="120000" extrusionOk="0">
+                <a:moveTo>
+                  <a:pt x="0" y="0"/>
+                </a:moveTo>
+                <a:lnTo>
+                  <a:pt x="120000" y="0"/>
+                </a:lnTo>
+                <a:lnTo>
+                  <a:pt x="120000" y="120000"/>
+                </a:lnTo>
+                <a:lnTo>
+                  <a:pt x="0" y="120000"/>
+                </a:lnTo>
+                <a:close/>
+              </a:path>
+            </a:pathLst>
+          </a:custGeom>
+          <a:noFill/>
+          <a:ln w="9525" cap="flat" cmpd="sng">
+            <a:solidFill>
+              <a:srgbClr val="000000"/>
+            </a:solidFill>
+            <a:prstDash val="solid"/>
+            <a:round/>
+            <a:headEnd type="none" w="sm" len="sm"/>
+            <a:tailEnd type="none" w="sm" len="sm"/>
+          </a:ln>
+        </p:spPr>
+        <p:txBody>
+          <a:bodyPr/>
+          <a:lstStyle/>
+          <a:p>
+            <a:endParaRPr lang="en-ZA"/>
+          </a:p>
+        </p:txBody>
+      </p:sp>
+    </p:spTree>
+  </p:cSld>
+  <p:clrMapOvr>
+    <a:masterClrMapping/>
+  </p:clrMapOvr>
+</p:notes>
+</file>
+
 <file path=ppt/notesSlides/notesSlide2.xml><?xml version="1.0" encoding="utf-8"?>
 <p:notes xmlns:a="http://schemas.openxmlformats.org/drawingml/2006/main" xmlns:r="http://schemas.openxmlformats.org/officeDocument/2006/relationships" xmlns:p="http://schemas.openxmlformats.org/presentationml/2006/main" showMasterSp="0" showMasterPhAnim="0">
   <p:cSld>
@@ -1418,6 +1548,158 @@
         <p:cNvPr id="1" name="Shape 54">
           <a:extLst>
             <a:ext uri="{FF2B5EF4-FFF2-40B4-BE49-F238E27FC236}">
+              <a16:creationId xmlns:a16="http://schemas.microsoft.com/office/drawing/2014/main" id="{7284EE27-A499-6FD6-A26E-8A433CC36A3D}"/>
+            </a:ext>
+          </a:extLst>
+        </p:cNvPr>
+        <p:cNvGrpSpPr/>
+        <p:nvPr/>
+      </p:nvGrpSpPr>
+      <p:grpSpPr>
+        <a:xfrm>
+          <a:off x="0" y="0"/>
+          <a:ext cx="0" cy="0"/>
+          <a:chOff x="0" y="0"/>
+          <a:chExt cx="0" cy="0"/>
+        </a:xfrm>
+      </p:grpSpPr>
+      <p:sp>
+        <p:nvSpPr>
+          <p:cNvPr id="55" name="Google Shape;55;p4:notes">
+            <a:extLst>
+              <a:ext uri="{FF2B5EF4-FFF2-40B4-BE49-F238E27FC236}">
+                <a16:creationId xmlns:a16="http://schemas.microsoft.com/office/drawing/2014/main" id="{88B99CEA-BF36-DB07-6CF1-E2F13AA53995}"/>
+              </a:ext>
+            </a:extLst>
+          </p:cNvPr>
+          <p:cNvSpPr txBox="1">
+            <a:spLocks noGrp="1"/>
+          </p:cNvSpPr>
+          <p:nvPr>
+            <p:ph type="body" idx="1"/>
+          </p:nvPr>
+        </p:nvSpPr>
+        <p:spPr>
+          <a:xfrm>
+            <a:off x="914400" y="4343400"/>
+            <a:ext cx="5029200" cy="4114800"/>
+          </a:xfrm>
+          <a:prstGeom prst="rect">
+            <a:avLst/>
+          </a:prstGeom>
+          <a:noFill/>
+          <a:ln>
+            <a:noFill/>
+          </a:ln>
+        </p:spPr>
+        <p:txBody>
+          <a:bodyPr spcFirstLastPara="1" wrap="square" lIns="91425" tIns="91425" rIns="91425" bIns="91425" anchor="t" anchorCtr="0">
+            <a:noAutofit/>
+          </a:bodyPr>
+          <a:lstStyle/>
+          <a:p>
+            <a:pPr marL="0" lvl="0" indent="0" algn="l" rtl="0">
+              <a:lnSpc>
+                <a:spcPct val="100000"/>
+              </a:lnSpc>
+              <a:spcBef>
+                <a:spcPts val="0"/>
+              </a:spcBef>
+              <a:spcAft>
+                <a:spcPts val="0"/>
+              </a:spcAft>
+              <a:buSzPts val="1100"/>
+              <a:buNone/>
+            </a:pPr>
+            <a:endParaRPr dirty="0"/>
+          </a:p>
+        </p:txBody>
+      </p:sp>
+      <p:sp>
+        <p:nvSpPr>
+          <p:cNvPr id="56" name="Google Shape;56;p4:notes">
+            <a:extLst>
+              <a:ext uri="{FF2B5EF4-FFF2-40B4-BE49-F238E27FC236}">
+                <a16:creationId xmlns:a16="http://schemas.microsoft.com/office/drawing/2014/main" id="{209112B2-2E35-1CB3-F270-35D19F899A0D}"/>
+              </a:ext>
+            </a:extLst>
+          </p:cNvPr>
+          <p:cNvSpPr>
+            <a:spLocks noGrp="1" noRot="1" noChangeAspect="1"/>
+          </p:cNvSpPr>
+          <p:nvPr>
+            <p:ph type="sldImg" idx="2"/>
+          </p:nvPr>
+        </p:nvSpPr>
+        <p:spPr>
+          <a:xfrm>
+            <a:off x="381000" y="685800"/>
+            <a:ext cx="6096000" cy="3429000"/>
+          </a:xfrm>
+          <a:custGeom>
+            <a:avLst/>
+            <a:gdLst/>
+            <a:ahLst/>
+            <a:cxnLst/>
+            <a:rect l="l" t="t" r="r" b="b"/>
+            <a:pathLst>
+              <a:path w="120000" h="120000" extrusionOk="0">
+                <a:moveTo>
+                  <a:pt x="0" y="0"/>
+                </a:moveTo>
+                <a:lnTo>
+                  <a:pt x="120000" y="0"/>
+                </a:lnTo>
+                <a:lnTo>
+                  <a:pt x="120000" y="120000"/>
+                </a:lnTo>
+                <a:lnTo>
+                  <a:pt x="0" y="120000"/>
+                </a:lnTo>
+                <a:close/>
+              </a:path>
+            </a:pathLst>
+          </a:custGeom>
+          <a:noFill/>
+          <a:ln w="9525" cap="flat" cmpd="sng">
+            <a:solidFill>
+              <a:srgbClr val="000000"/>
+            </a:solidFill>
+            <a:prstDash val="solid"/>
+            <a:round/>
+            <a:headEnd type="none" w="sm" len="sm"/>
+            <a:tailEnd type="none" w="sm" len="sm"/>
+          </a:ln>
+        </p:spPr>
+        <p:txBody>
+          <a:bodyPr/>
+          <a:lstStyle/>
+          <a:p>
+            <a:endParaRPr lang="en-ZA"/>
+          </a:p>
+        </p:txBody>
+      </p:sp>
+    </p:spTree>
+    <p:extLst>
+      <p:ext uri="{BB962C8B-B14F-4D97-AF65-F5344CB8AC3E}">
+        <p14:creationId xmlns:p14="http://schemas.microsoft.com/office/powerpoint/2010/main" val="250343426"/>
+      </p:ext>
+    </p:extLst>
+  </p:cSld>
+  <p:clrMapOvr>
+    <a:masterClrMapping/>
+  </p:clrMapOvr>
+</p:notes>
+</file>
+
+<file path=ppt/notesSlides/notesSlide6.xml><?xml version="1.0" encoding="utf-8"?>
+<p:notes xmlns:a="http://schemas.openxmlformats.org/drawingml/2006/main" xmlns:r="http://schemas.openxmlformats.org/officeDocument/2006/relationships" xmlns:p="http://schemas.openxmlformats.org/presentationml/2006/main" showMasterSp="0" showMasterPhAnim="0">
+  <p:cSld>
+    <p:spTree>
+      <p:nvGrpSpPr>
+        <p:cNvPr id="1" name="Shape 54">
+          <a:extLst>
+            <a:ext uri="{FF2B5EF4-FFF2-40B4-BE49-F238E27FC236}">
               <a16:creationId xmlns:a16="http://schemas.microsoft.com/office/drawing/2014/main" id="{03A032A4-D30D-BE5B-CB22-A639829E60C4}"/>
             </a:ext>
           </a:extLst>
@@ -1562,7 +1844,7 @@
 </p:notes>
 </file>
 
-<file path=ppt/notesSlides/notesSlide6.xml><?xml version="1.0" encoding="utf-8"?>
+<file path=ppt/notesSlides/notesSlide7.xml><?xml version="1.0" encoding="utf-8"?>
 <p:notes xmlns:a="http://schemas.openxmlformats.org/drawingml/2006/main" xmlns:r="http://schemas.openxmlformats.org/officeDocument/2006/relationships" xmlns:p="http://schemas.openxmlformats.org/presentationml/2006/main" showMasterSp="0" showMasterPhAnim="0">
   <p:cSld>
     <p:spTree>
@@ -1714,7 +1996,7 @@
 </p:notes>
 </file>
 
-<file path=ppt/notesSlides/notesSlide7.xml><?xml version="1.0" encoding="utf-8"?>
+<file path=ppt/notesSlides/notesSlide8.xml><?xml version="1.0" encoding="utf-8"?>
 <p:notes xmlns:a="http://schemas.openxmlformats.org/drawingml/2006/main" xmlns:r="http://schemas.openxmlformats.org/officeDocument/2006/relationships" xmlns:p="http://schemas.openxmlformats.org/presentationml/2006/main" showMasterSp="0" showMasterPhAnim="0">
   <p:cSld>
     <p:spTree>
@@ -1843,7 +2125,7 @@
 </p:notes>
 </file>
 
-<file path=ppt/notesSlides/notesSlide8.xml><?xml version="1.0" encoding="utf-8"?>
+<file path=ppt/notesSlides/notesSlide9.xml><?xml version="1.0" encoding="utf-8"?>
 <p:notes xmlns:a="http://schemas.openxmlformats.org/drawingml/2006/main" xmlns:r="http://schemas.openxmlformats.org/officeDocument/2006/relationships" xmlns:p="http://schemas.openxmlformats.org/presentationml/2006/main" showMasterSp="0" showMasterPhAnim="0">
   <p:cSld>
     <p:spTree>
@@ -1920,135 +2202,6 @@
           <a:xfrm>
             <a:off x="381000" y="685800"/>
             <a:ext cx="6096000" cy="3429000"/>
-          </a:xfrm>
-          <a:custGeom>
-            <a:avLst/>
-            <a:gdLst/>
-            <a:ahLst/>
-            <a:cxnLst/>
-            <a:rect l="l" t="t" r="r" b="b"/>
-            <a:pathLst>
-              <a:path w="120000" h="120000" extrusionOk="0">
-                <a:moveTo>
-                  <a:pt x="0" y="0"/>
-                </a:moveTo>
-                <a:lnTo>
-                  <a:pt x="120000" y="0"/>
-                </a:lnTo>
-                <a:lnTo>
-                  <a:pt x="120000" y="120000"/>
-                </a:lnTo>
-                <a:lnTo>
-                  <a:pt x="0" y="120000"/>
-                </a:lnTo>
-                <a:close/>
-              </a:path>
-            </a:pathLst>
-          </a:custGeom>
-          <a:noFill/>
-          <a:ln w="9525" cap="flat" cmpd="sng">
-            <a:solidFill>
-              <a:srgbClr val="000000"/>
-            </a:solidFill>
-            <a:prstDash val="solid"/>
-            <a:round/>
-            <a:headEnd type="none" w="sm" len="sm"/>
-            <a:tailEnd type="none" w="sm" len="sm"/>
-          </a:ln>
-        </p:spPr>
-        <p:txBody>
-          <a:bodyPr/>
-          <a:lstStyle/>
-          <a:p>
-            <a:endParaRPr lang="en-ZA"/>
-          </a:p>
-        </p:txBody>
-      </p:sp>
-    </p:spTree>
-  </p:cSld>
-  <p:clrMapOvr>
-    <a:masterClrMapping/>
-  </p:clrMapOvr>
-</p:notes>
-</file>
-
-<file path=ppt/notesSlides/notesSlide9.xml><?xml version="1.0" encoding="utf-8"?>
-<p:notes xmlns:a="http://schemas.openxmlformats.org/drawingml/2006/main" xmlns:r="http://schemas.openxmlformats.org/officeDocument/2006/relationships" xmlns:p="http://schemas.openxmlformats.org/presentationml/2006/main" showMasterSp="0" showMasterPhAnim="0">
-  <p:cSld>
-    <p:spTree>
-      <p:nvGrpSpPr>
-        <p:cNvPr id="1" name="Shape 78"/>
-        <p:cNvGrpSpPr/>
-        <p:nvPr/>
-      </p:nvGrpSpPr>
-      <p:grpSpPr>
-        <a:xfrm>
-          <a:off x="0" y="0"/>
-          <a:ext cx="0" cy="0"/>
-          <a:chOff x="0" y="0"/>
-          <a:chExt cx="0" cy="0"/>
-        </a:xfrm>
-      </p:grpSpPr>
-      <p:sp>
-        <p:nvSpPr>
-          <p:cNvPr id="79" name="Google Shape;79;p7:notes"/>
-          <p:cNvSpPr txBox="1">
-            <a:spLocks noGrp="1"/>
-          </p:cNvSpPr>
-          <p:nvPr>
-            <p:ph type="body" idx="1"/>
-          </p:nvPr>
-        </p:nvSpPr>
-        <p:spPr>
-          <a:xfrm>
-            <a:off x="914400" y="4343400"/>
-            <a:ext cx="5029200" cy="4114800"/>
-          </a:xfrm>
-          <a:prstGeom prst="rect">
-            <a:avLst/>
-          </a:prstGeom>
-          <a:noFill/>
-          <a:ln>
-            <a:noFill/>
-          </a:ln>
-        </p:spPr>
-        <p:txBody>
-          <a:bodyPr spcFirstLastPara="1" wrap="square" lIns="91425" tIns="91425" rIns="91425" bIns="91425" anchor="t" anchorCtr="0">
-            <a:noAutofit/>
-          </a:bodyPr>
-          <a:lstStyle/>
-          <a:p>
-            <a:pPr marL="0" lvl="0" indent="0" algn="l" rtl="0">
-              <a:lnSpc>
-                <a:spcPct val="100000"/>
-              </a:lnSpc>
-              <a:spcBef>
-                <a:spcPts val="0"/>
-              </a:spcBef>
-              <a:spcAft>
-                <a:spcPts val="0"/>
-              </a:spcAft>
-              <a:buSzPts val="1100"/>
-              <a:buNone/>
-            </a:pPr>
-            <a:endParaRPr/>
-          </a:p>
-        </p:txBody>
-      </p:sp>
-      <p:sp>
-        <p:nvSpPr>
-          <p:cNvPr id="80" name="Google Shape;80;p7:notes"/>
-          <p:cNvSpPr>
-            <a:spLocks noGrp="1" noRot="1" noChangeAspect="1"/>
-          </p:cNvSpPr>
-          <p:nvPr>
-            <p:ph type="sldImg" idx="2"/>
-          </p:nvPr>
-        </p:nvSpPr>
-        <p:spPr>
-          <a:xfrm>
-            <a:off x="1143000" y="685800"/>
-            <a:ext cx="4572000" cy="3429000"/>
           </a:xfrm>
           <a:custGeom>
             <a:avLst/>
@@ -5091,6 +5244,124 @@
 </p:sld>
 </file>
 
+<file path=ppt/slides/slide10.xml><?xml version="1.0" encoding="utf-8"?>
+<p:sld xmlns:a="http://schemas.openxmlformats.org/drawingml/2006/main" xmlns:r="http://schemas.openxmlformats.org/officeDocument/2006/relationships" xmlns:p="http://schemas.openxmlformats.org/presentationml/2006/main">
+  <p:cSld>
+    <p:spTree>
+      <p:nvGrpSpPr>
+        <p:cNvPr id="1" name="Shape 81"/>
+        <p:cNvGrpSpPr/>
+        <p:nvPr/>
+      </p:nvGrpSpPr>
+      <p:grpSpPr>
+        <a:xfrm>
+          <a:off x="0" y="0"/>
+          <a:ext cx="0" cy="0"/>
+          <a:chOff x="0" y="0"/>
+          <a:chExt cx="0" cy="0"/>
+        </a:xfrm>
+      </p:grpSpPr>
+      <p:sp>
+        <p:nvSpPr>
+          <p:cNvPr id="82" name="Google Shape;82;p13"/>
+          <p:cNvSpPr txBox="1"/>
+          <p:nvPr/>
+        </p:nvSpPr>
+        <p:spPr>
+          <a:xfrm>
+            <a:off x="405300" y="2187725"/>
+            <a:ext cx="8260500" cy="1979700"/>
+          </a:xfrm>
+          <a:prstGeom prst="rect">
+            <a:avLst/>
+          </a:prstGeom>
+          <a:noFill/>
+          <a:ln>
+            <a:noFill/>
+          </a:ln>
+        </p:spPr>
+        <p:txBody>
+          <a:bodyPr spcFirstLastPara="1" wrap="square" lIns="91425" tIns="91425" rIns="91425" bIns="91425" anchor="t" anchorCtr="0">
+            <a:noAutofit/>
+          </a:bodyPr>
+          <a:lstStyle/>
+          <a:p>
+            <a:pPr marL="0" marR="0" lvl="0" indent="0" algn="ctr" rtl="0">
+              <a:lnSpc>
+                <a:spcPct val="100000"/>
+              </a:lnSpc>
+              <a:spcBef>
+                <a:spcPts val="0"/>
+              </a:spcBef>
+              <a:spcAft>
+                <a:spcPts val="0"/>
+              </a:spcAft>
+              <a:buClr>
+                <a:srgbClr val="000000"/>
+              </a:buClr>
+              <a:buSzPts val="3000"/>
+              <a:buFont typeface="Arial"/>
+              <a:buNone/>
+            </a:pPr>
+            <a:r>
+              <a:rPr lang="en" sz="3000" b="0" i="0" u="none" strike="noStrike" cap="none">
+                <a:solidFill>
+                  <a:schemeClr val="lt1"/>
+                </a:solidFill>
+                <a:latin typeface="Titillium Web"/>
+                <a:ea typeface="Titillium Web"/>
+                <a:cs typeface="Titillium Web"/>
+                <a:sym typeface="Titillium Web"/>
+              </a:rPr>
+              <a:t>Thank you.</a:t>
+            </a:r>
+            <a:endParaRPr sz="3000" b="0" i="0" u="none" strike="noStrike" cap="none">
+              <a:solidFill>
+                <a:schemeClr val="lt1"/>
+              </a:solidFill>
+              <a:latin typeface="Titillium Web"/>
+              <a:ea typeface="Titillium Web"/>
+              <a:cs typeface="Titillium Web"/>
+              <a:sym typeface="Titillium Web"/>
+            </a:endParaRPr>
+          </a:p>
+        </p:txBody>
+      </p:sp>
+      <p:pic>
+        <p:nvPicPr>
+          <p:cNvPr id="83" name="Google Shape;83;p13" title="0048_FIH_Logo-White.png"/>
+          <p:cNvPicPr preferRelativeResize="0"/>
+          <p:nvPr/>
+        </p:nvPicPr>
+        <p:blipFill rotWithShape="1">
+          <a:blip r:embed="rId3">
+            <a:alphaModFix/>
+          </a:blip>
+          <a:srcRect/>
+          <a:stretch/>
+        </p:blipFill>
+        <p:spPr>
+          <a:xfrm>
+            <a:off x="261755" y="203243"/>
+            <a:ext cx="1371602" cy="330797"/>
+          </a:xfrm>
+          <a:prstGeom prst="rect">
+            <a:avLst/>
+          </a:prstGeom>
+          <a:noFill/>
+          <a:ln>
+            <a:noFill/>
+          </a:ln>
+        </p:spPr>
+      </p:pic>
+    </p:spTree>
+  </p:cSld>
+  <p:clrMapOvr>
+    <a:masterClrMapping/>
+  </p:clrMapOvr>
+</p:sld>
+</file>
+
 <file path=ppt/slides/slide2.xml><?xml version="1.0" encoding="utf-8"?>
 <p:sld xmlns:a="http://schemas.openxmlformats.org/drawingml/2006/main" xmlns:r="http://schemas.openxmlformats.org/officeDocument/2006/relationships" xmlns:p="http://schemas.openxmlformats.org/presentationml/2006/main">
   <p:cSld>
@@ -5980,7 +6251,7 @@
                 <a:latin typeface="Titillium Web"/>
                 <a:sym typeface="Titillium Web"/>
               </a:rPr>
-              <a:t>Solution</a:t>
+              <a:t>GYM Solution</a:t>
             </a:r>
             <a:endParaRPr sz="500" b="0" i="0" u="none" strike="noStrike" cap="none" dirty="0">
               <a:solidFill>
@@ -6098,6 +6369,212 @@
         <p:cNvPr id="1" name="Shape 57">
           <a:extLst>
             <a:ext uri="{FF2B5EF4-FFF2-40B4-BE49-F238E27FC236}">
+              <a16:creationId xmlns:a16="http://schemas.microsoft.com/office/drawing/2014/main" id="{B0157CEB-6F99-3F9B-D354-07FF65C2D39C}"/>
+            </a:ext>
+          </a:extLst>
+        </p:cNvPr>
+        <p:cNvGrpSpPr/>
+        <p:nvPr/>
+      </p:nvGrpSpPr>
+      <p:grpSpPr>
+        <a:xfrm>
+          <a:off x="0" y="0"/>
+          <a:ext cx="0" cy="0"/>
+          <a:chOff x="0" y="0"/>
+          <a:chExt cx="0" cy="0"/>
+        </a:xfrm>
+      </p:grpSpPr>
+      <p:sp>
+        <p:nvSpPr>
+          <p:cNvPr id="58" name="Google Shape;58;p10">
+            <a:extLst>
+              <a:ext uri="{FF2B5EF4-FFF2-40B4-BE49-F238E27FC236}">
+                <a16:creationId xmlns:a16="http://schemas.microsoft.com/office/drawing/2014/main" id="{BFACD348-5A68-9A51-0D4C-B08352746DB2}"/>
+              </a:ext>
+            </a:extLst>
+          </p:cNvPr>
+          <p:cNvSpPr txBox="1"/>
+          <p:nvPr/>
+        </p:nvSpPr>
+        <p:spPr>
+          <a:xfrm>
+            <a:off x="2095551" y="368641"/>
+            <a:ext cx="4620900" cy="647881"/>
+          </a:xfrm>
+          <a:prstGeom prst="rect">
+            <a:avLst/>
+          </a:prstGeom>
+          <a:noFill/>
+          <a:ln>
+            <a:noFill/>
+          </a:ln>
+        </p:spPr>
+        <p:txBody>
+          <a:bodyPr spcFirstLastPara="1" wrap="square" lIns="19050" tIns="19050" rIns="19050" bIns="19050" anchor="t" anchorCtr="0">
+            <a:normAutofit/>
+          </a:bodyPr>
+          <a:lstStyle/>
+          <a:p>
+            <a:pPr marL="0" marR="0" lvl="0" indent="0" algn="l" rtl="0">
+              <a:lnSpc>
+                <a:spcPct val="90000"/>
+              </a:lnSpc>
+              <a:spcBef>
+                <a:spcPts val="0"/>
+              </a:spcBef>
+              <a:spcAft>
+                <a:spcPts val="0"/>
+              </a:spcAft>
+              <a:buClr>
+                <a:srgbClr val="7100F4"/>
+              </a:buClr>
+              <a:buSzPts val="3900"/>
+              <a:buFont typeface="Titillium Web"/>
+              <a:buNone/>
+            </a:pPr>
+            <a:r>
+              <a:rPr lang="en" sz="3900" b="1" dirty="0">
+                <a:solidFill>
+                  <a:srgbClr val="00E296"/>
+                </a:solidFill>
+                <a:latin typeface="Titillium Web"/>
+                <a:sym typeface="Titillium Web"/>
+              </a:rPr>
+              <a:t>Streaming Solution</a:t>
+            </a:r>
+            <a:endParaRPr sz="500" b="0" i="0" u="none" strike="noStrike" cap="none" dirty="0">
+              <a:solidFill>
+                <a:srgbClr val="00E296"/>
+              </a:solidFill>
+              <a:latin typeface="Arial"/>
+              <a:ea typeface="Arial"/>
+              <a:cs typeface="Arial"/>
+              <a:sym typeface="Arial"/>
+            </a:endParaRPr>
+          </a:p>
+        </p:txBody>
+      </p:sp>
+      <p:cxnSp>
+        <p:nvCxnSpPr>
+          <p:cNvPr id="60" name="Google Shape;60;p10">
+            <a:extLst>
+              <a:ext uri="{FF2B5EF4-FFF2-40B4-BE49-F238E27FC236}">
+                <a16:creationId xmlns:a16="http://schemas.microsoft.com/office/drawing/2014/main" id="{A769BE32-7354-9B3A-8178-243828166144}"/>
+              </a:ext>
+            </a:extLst>
+          </p:cNvPr>
+          <p:cNvCxnSpPr>
+            <a:cxnSpLocks/>
+          </p:cNvCxnSpPr>
+          <p:nvPr/>
+        </p:nvCxnSpPr>
+        <p:spPr>
+          <a:xfrm>
+            <a:off x="349420" y="990615"/>
+            <a:ext cx="8223078" cy="0"/>
+          </a:xfrm>
+          <a:prstGeom prst="straightConnector1">
+            <a:avLst/>
+          </a:prstGeom>
+          <a:noFill/>
+          <a:ln w="9525" cap="flat" cmpd="sng">
+            <a:solidFill>
+              <a:srgbClr val="00E296"/>
+            </a:solidFill>
+            <a:prstDash val="solid"/>
+            <a:round/>
+            <a:headEnd type="none" w="sm" len="sm"/>
+            <a:tailEnd type="stealth" w="med" len="med"/>
+          </a:ln>
+        </p:spPr>
+      </p:cxnSp>
+      <p:pic>
+        <p:nvPicPr>
+          <p:cNvPr id="61" name="Google Shape;61;p10" title="0048_FIH_Logo-White.png">
+            <a:extLst>
+              <a:ext uri="{FF2B5EF4-FFF2-40B4-BE49-F238E27FC236}">
+                <a16:creationId xmlns:a16="http://schemas.microsoft.com/office/drawing/2014/main" id="{B8491E6F-5364-4828-3985-C4ECB239B513}"/>
+              </a:ext>
+            </a:extLst>
+          </p:cNvPr>
+          <p:cNvPicPr preferRelativeResize="0"/>
+          <p:nvPr/>
+        </p:nvPicPr>
+        <p:blipFill rotWithShape="1">
+          <a:blip r:embed="rId3">
+            <a:alphaModFix/>
+          </a:blip>
+          <a:srcRect/>
+          <a:stretch/>
+        </p:blipFill>
+        <p:spPr>
+          <a:xfrm>
+            <a:off x="261755" y="203243"/>
+            <a:ext cx="1371602" cy="330797"/>
+          </a:xfrm>
+          <a:prstGeom prst="rect">
+            <a:avLst/>
+          </a:prstGeom>
+          <a:noFill/>
+          <a:ln>
+            <a:noFill/>
+          </a:ln>
+        </p:spPr>
+      </p:pic>
+      <p:pic>
+        <p:nvPicPr>
+          <p:cNvPr id="3" name="Picture 2">
+            <a:extLst>
+              <a:ext uri="{FF2B5EF4-FFF2-40B4-BE49-F238E27FC236}">
+                <a16:creationId xmlns:a16="http://schemas.microsoft.com/office/drawing/2014/main" id="{FCD8EB45-9CB3-31AD-08ED-B5D10E6026B3}"/>
+              </a:ext>
+            </a:extLst>
+          </p:cNvPr>
+          <p:cNvPicPr>
+            <a:picLocks noChangeAspect="1"/>
+          </p:cNvPicPr>
+          <p:nvPr/>
+        </p:nvPicPr>
+        <p:blipFill>
+          <a:blip r:embed="rId4"/>
+          <a:stretch>
+            <a:fillRect/>
+          </a:stretch>
+        </p:blipFill>
+        <p:spPr>
+          <a:xfrm>
+            <a:off x="51592" y="1156014"/>
+            <a:ext cx="9040815" cy="3490325"/>
+          </a:xfrm>
+          <a:prstGeom prst="rect">
+            <a:avLst/>
+          </a:prstGeom>
+        </p:spPr>
+      </p:pic>
+    </p:spTree>
+    <p:extLst>
+      <p:ext uri="{BB962C8B-B14F-4D97-AF65-F5344CB8AC3E}">
+        <p14:creationId xmlns:p14="http://schemas.microsoft.com/office/powerpoint/2010/main" val="330894509"/>
+      </p:ext>
+    </p:extLst>
+  </p:cSld>
+  <p:clrMapOvr>
+    <a:masterClrMapping/>
+  </p:clrMapOvr>
+  <p:transition spd="slow">
+    <p:wipe/>
+  </p:transition>
+</p:sld>
+</file>
+
+<file path=ppt/slides/slide6.xml><?xml version="1.0" encoding="utf-8"?>
+<p:sld xmlns:a="http://schemas.openxmlformats.org/drawingml/2006/main" xmlns:r="http://schemas.openxmlformats.org/officeDocument/2006/relationships" xmlns:p="http://schemas.openxmlformats.org/presentationml/2006/main">
+  <p:cSld>
+    <p:spTree>
+      <p:nvGrpSpPr>
+        <p:cNvPr id="1" name="Shape 57">
+          <a:extLst>
+            <a:ext uri="{FF2B5EF4-FFF2-40B4-BE49-F238E27FC236}">
               <a16:creationId xmlns:a16="http://schemas.microsoft.com/office/drawing/2014/main" id="{90F2F238-2765-EA10-CE4B-274AAF0B244A}"/>
             </a:ext>
           </a:extLst>
@@ -6353,7 +6830,7 @@
 </p:sld>
 </file>
 
-<file path=ppt/slides/slide6.xml><?xml version="1.0" encoding="utf-8"?>
+<file path=ppt/slides/slide7.xml><?xml version="1.0" encoding="utf-8"?>
 <p:sld xmlns:a="http://schemas.openxmlformats.org/drawingml/2006/main" xmlns:r="http://schemas.openxmlformats.org/officeDocument/2006/relationships" xmlns:p="http://schemas.openxmlformats.org/presentationml/2006/main">
   <p:cSld>
     <p:spTree>
@@ -6604,7 +7081,7 @@
 </p:sld>
 </file>
 
-<file path=ppt/slides/slide7.xml><?xml version="1.0" encoding="utf-8"?>
+<file path=ppt/slides/slide8.xml><?xml version="1.0" encoding="utf-8"?>
 <p:sld xmlns:a="http://schemas.openxmlformats.org/drawingml/2006/main" xmlns:r="http://schemas.openxmlformats.org/officeDocument/2006/relationships" xmlns:p="http://schemas.openxmlformats.org/presentationml/2006/main">
   <p:cSld>
     <p:spTree>
@@ -6748,7 +7225,7 @@
 </p:sld>
 </file>
 
-<file path=ppt/slides/slide8.xml><?xml version="1.0" encoding="utf-8"?>
+<file path=ppt/slides/slide9.xml><?xml version="1.0" encoding="utf-8"?>
 <p:sld xmlns:a="http://schemas.openxmlformats.org/drawingml/2006/main" xmlns:r="http://schemas.openxmlformats.org/officeDocument/2006/relationships" xmlns:p="http://schemas.openxmlformats.org/presentationml/2006/main">
   <p:cSld>
     <p:spTree>
@@ -6931,124 +7408,6 @@
       <p:pic>
         <p:nvPicPr>
           <p:cNvPr id="77" name="Google Shape;77;p12" title="0048_FIH_Logo-White.png"/>
-          <p:cNvPicPr preferRelativeResize="0"/>
-          <p:nvPr/>
-        </p:nvPicPr>
-        <p:blipFill rotWithShape="1">
-          <a:blip r:embed="rId3">
-            <a:alphaModFix/>
-          </a:blip>
-          <a:srcRect/>
-          <a:stretch/>
-        </p:blipFill>
-        <p:spPr>
-          <a:xfrm>
-            <a:off x="261755" y="203243"/>
-            <a:ext cx="1371602" cy="330797"/>
-          </a:xfrm>
-          <a:prstGeom prst="rect">
-            <a:avLst/>
-          </a:prstGeom>
-          <a:noFill/>
-          <a:ln>
-            <a:noFill/>
-          </a:ln>
-        </p:spPr>
-      </p:pic>
-    </p:spTree>
-  </p:cSld>
-  <p:clrMapOvr>
-    <a:masterClrMapping/>
-  </p:clrMapOvr>
-</p:sld>
-</file>
-
-<file path=ppt/slides/slide9.xml><?xml version="1.0" encoding="utf-8"?>
-<p:sld xmlns:a="http://schemas.openxmlformats.org/drawingml/2006/main" xmlns:r="http://schemas.openxmlformats.org/officeDocument/2006/relationships" xmlns:p="http://schemas.openxmlformats.org/presentationml/2006/main">
-  <p:cSld>
-    <p:spTree>
-      <p:nvGrpSpPr>
-        <p:cNvPr id="1" name="Shape 81"/>
-        <p:cNvGrpSpPr/>
-        <p:nvPr/>
-      </p:nvGrpSpPr>
-      <p:grpSpPr>
-        <a:xfrm>
-          <a:off x="0" y="0"/>
-          <a:ext cx="0" cy="0"/>
-          <a:chOff x="0" y="0"/>
-          <a:chExt cx="0" cy="0"/>
-        </a:xfrm>
-      </p:grpSpPr>
-      <p:sp>
-        <p:nvSpPr>
-          <p:cNvPr id="82" name="Google Shape;82;p13"/>
-          <p:cNvSpPr txBox="1"/>
-          <p:nvPr/>
-        </p:nvSpPr>
-        <p:spPr>
-          <a:xfrm>
-            <a:off x="405300" y="2187725"/>
-            <a:ext cx="8260500" cy="1979700"/>
-          </a:xfrm>
-          <a:prstGeom prst="rect">
-            <a:avLst/>
-          </a:prstGeom>
-          <a:noFill/>
-          <a:ln>
-            <a:noFill/>
-          </a:ln>
-        </p:spPr>
-        <p:txBody>
-          <a:bodyPr spcFirstLastPara="1" wrap="square" lIns="91425" tIns="91425" rIns="91425" bIns="91425" anchor="t" anchorCtr="0">
-            <a:noAutofit/>
-          </a:bodyPr>
-          <a:lstStyle/>
-          <a:p>
-            <a:pPr marL="0" marR="0" lvl="0" indent="0" algn="ctr" rtl="0">
-              <a:lnSpc>
-                <a:spcPct val="100000"/>
-              </a:lnSpc>
-              <a:spcBef>
-                <a:spcPts val="0"/>
-              </a:spcBef>
-              <a:spcAft>
-                <a:spcPts val="0"/>
-              </a:spcAft>
-              <a:buClr>
-                <a:srgbClr val="000000"/>
-              </a:buClr>
-              <a:buSzPts val="3000"/>
-              <a:buFont typeface="Arial"/>
-              <a:buNone/>
-            </a:pPr>
-            <a:r>
-              <a:rPr lang="en" sz="3000" b="0" i="0" u="none" strike="noStrike" cap="none">
-                <a:solidFill>
-                  <a:schemeClr val="lt1"/>
-                </a:solidFill>
-                <a:latin typeface="Titillium Web"/>
-                <a:ea typeface="Titillium Web"/>
-                <a:cs typeface="Titillium Web"/>
-                <a:sym typeface="Titillium Web"/>
-              </a:rPr>
-              <a:t>Thank you.</a:t>
-            </a:r>
-            <a:endParaRPr sz="3000" b="0" i="0" u="none" strike="noStrike" cap="none">
-              <a:solidFill>
-                <a:schemeClr val="lt1"/>
-              </a:solidFill>
-              <a:latin typeface="Titillium Web"/>
-              <a:ea typeface="Titillium Web"/>
-              <a:cs typeface="Titillium Web"/>
-              <a:sym typeface="Titillium Web"/>
-            </a:endParaRPr>
-          </a:p>
-        </p:txBody>
-      </p:sp>
-      <p:pic>
-        <p:nvPicPr>
-          <p:cNvPr id="83" name="Google Shape;83;p13" title="0048_FIH_Logo-White.png"/>
           <p:cNvPicPr preferRelativeResize="0"/>
           <p:nvPr/>
         </p:nvPicPr>

</xml_diff>